<commit_message>
V9.4.2: agrega al segundo integrante en los documentos
El encargo de EP1 se desarrolla en parejas, asi que la portada del informe y la
de la presentacion incluyen a los dos integrantes y sus correos.

El cambio se aplica en las tres fuentes -informe.html, presentacion.html y
construir-pptx.py- y los tres documentos se regeneran desde ellas, de modo que
no queda ninguna portada desactualizada.
</commit_message>
<xml_diff>
--- a/docs/presentacion/Pedidos360-presentacion.pptx
+++ b/docs/presentacion/Pedidos360-presentacion.pptx
@@ -3304,7 +3304,7 @@
                 </a:solidFill>
                 <a:latin typeface="Calibri"/>
               </a:rPr>
-              <a:t>ESTUDIANTE</a:t>
+              <a:t>ESTUDIANTES</a:t>
             </a:r>
           </a:p>
           <a:p>
@@ -3324,6 +3324,25 @@
                 <a:latin typeface="Calibri"/>
               </a:rPr>
               <a:t>Ismael Oyarzun Montiel</a:t>
+            </a:r>
+          </a:p>
+          <a:p>
+            <a:pPr algn="l">
+              <a:lnSpc>
+                <a:spcPct val="135000"/>
+              </a:lnSpc>
+              <a:spcAft>
+                <a:spcPts val="0"/>
+              </a:spcAft>
+            </a:pPr>
+            <a:r>
+              <a:rPr sz="1200" b="0" i="0">
+                <a:solidFill>
+                  <a:srgbClr val="A8B0BF"/>
+                </a:solidFill>
+                <a:latin typeface="Calibri"/>
+              </a:rPr>
+              <a:t>Diego Villota</a:t>
             </a:r>
           </a:p>
         </p:txBody>

</xml_diff>